<commit_message>
Add 7-minute pitch script to v4.0 Pearl speaker notes
Co-Authored-By: Claude Opus 5.5 <noreply@anthropic.com>
Claude-Session: https://claude.ai/code/session_017QB5LGF7rtAPE1GUPfCLTP
</commit_message>
<xml_diff>
--- a/FastPass_Deck/FastPass_InnoChamp2026_v4.0_Pearl.pptx
+++ b/FastPass_Deck/FastPass_InnoChamp2026_v4.0_Pearl.pptx
@@ -121,7 +121,7 @@
   <p:extLst>
     <p:ext uri="{521415D9-36F7-43E2-AB2F-B90AF26B5E84}">
       <p14:sectionLst xmlns:p14="http://schemas.microsoft.com/office/powerpoint/2010/main">
-        <p14:section name="Pitch" id="{5ab0ed74-a041-2b34-fff2-409cbd7b8d7b}">
+        <p14:section name="Pitch" id="{e5cc03de-c68e-b2b9-cb55-2e71da9841ca}">
           <p14:sldIdLst>
             <p14:sldId id="256"/>
             <p14:sldId id="257"/>
@@ -136,7 +136,7 @@
             <p14:sldId id="266"/>
           </p14:sldIdLst>
         </p14:section>
-        <p14:section name="Appendix" id="{9040d357-6f22-7523-5b70-7ea270a28caa}">
+        <p14:section name="Appendix" id="{350d08e8-8942-48d5-09cc-834173be8aca}">
           <p14:sldIdLst>
             <p14:sldId id="267"/>
             <p14:sldId id="268"/>
@@ -548,8 +548,9 @@
           <a:p>
             <a:r>
               <a:rPr lang="en-US" dirty="0"/>
-              <a:t>[0:00–0:10]  AGIL® Secure FastPass — curb to gate on one verified identity. Two-factor, privacy-first, modular.
-TIME PLAN (8-min slot): 1 Cover 0:10 · 2 Needs 0:45 · 3 Market 0:50 · 4 Journey 1:10 · 5 ISMP 0:35 · 6 Innovation 0:50 · 7 Impact 0:40 · 8 Go-to-market 0:50 · 9 Collaboration &amp; barriers 0:45 · 10 Ready &amp; ask 0:40 · 11 Close 0:05 ≈ 7:20.</a:t>
+              <a:t>[0:00–0:15]  Cover
+Good morning. I'm [Name]. With colleagues across Smart Security &amp; Automation, Smart Utilities &amp; Infrastructure and Urban Solutions, we built AGIL Secure FastPass.
+Our idea is simple: curb to gate, on one verified identity.</a:t>
             </a:r>
             <a:endParaRPr lang="en-US" dirty="0"/>
           </a:p>
@@ -637,9 +638,10 @@
           <a:p>
             <a:r>
               <a:rPr lang="en-US" dirty="0"/>
-              <a:t>[6:35–7:15]  Four reasons, in order: a clear operational need; a focused US$100–140M-a-year market; a working, integrated product shown at Singapore Airshow 2026; and a defensible edge — the two-factor credential converged with security operations.
-Path: live demo with airport stakeholders this quarter → PT World Amsterdam in April → first customer pilot in 2027.
-Our ask (CEO: "what do we need STMG to support — money, resource"): productisation funding for offline mode, redundancy and back-end integration [insert amount]; a launch customer through Group Sales; and the PT World 2027 showcase.</a:t>
+              <a:t>[6:10–6:50]  Conclusion &amp; Ask
+So, four reasons to back FastPass now. A clear need. A focused market. A working product, shown live at the Singapore Airshow this year. And an edge that is hard to copy.
+Next comes a live demo with airport stakeholders this quarter, Passenger Terminal World in Amsterdam next April, and our first customer pilot in 2027.
+To get there, we ask for three things: funding to turn the prototype into a product, a launch customer through Group Sales, and support to showcase FastPass at Passenger Terminal World 2027.</a:t>
             </a:r>
             <a:endParaRPr lang="en-US" dirty="0"/>
           </a:p>
@@ -727,7 +729,8 @@
           <a:p>
             <a:r>
               <a:rPr lang="en-US" dirty="0"/>
-              <a:t>[7:15–7:20]  Thank you — happy to take questions. References and Q&amp;A backup follow.</a:t>
+              <a:t>[6:50–6:55]  Thank you
+One identity, from curb to gate. Thank you. We're happy to take your questions.</a:t>
             </a:r>
             <a:endParaRPr lang="en-US" dirty="0"/>
           </a:p>
@@ -1167,12 +1170,11 @@
           <a:p>
             <a:r>
               <a:rPr lang="en-US" dirty="0"/>
-              <a:t>[0:10–0:55]  The departure journey is fragmented: check-in, immigration, security screening and boarding each ask for identity again — the icons show the documents each stop needs.
-• 4 identity checks per departure; each is a stop and a queue.
-• At least one officer staffs every touchpoint, so capacity is tied to routine checks.
-• Demand doubles by 2040 (IATA, Dec 2023: 7.8 bn passengers).
-• New capacity takes a decade: Changi's Terminal 5 broke ground in 2025 and opens in the mid-2030s.
-Change from draft: the "48% of airports by 2027" figure is replaced — it could not be traced to SITA's published reports.</a:t>
+              <a:t>[0:15–0:55]  Market Needs
+Let's start with the problem.
+Think about your last flight. You showed your passport at check-in. Again at immigration. Again at security. And again at the gate. Four checks. Four stops. Four queues. And at every stop, there is at least one officer doing routine work.
+The pressure keeps growing. Air travel will double by 2040. But new terminals take years. Changi's next terminal will not open until the 2030s.
+So airports must move more people, with the space and staff they already have.</a:t>
             </a:r>
             <a:endParaRPr lang="en-US" dirty="0"/>
           </a:p>
@@ -1260,9 +1262,11 @@
           <a:p>
             <a:r>
               <a:rPr lang="en-US" dirty="0"/>
-              <a:t>[0:55–1:45]  Bottom-up sizing: automated border control US$2.56B (2025) → US$5.03B (2030), 14.4% a year (MarketsandMarkets); airports are ~83% of it; ME + SEA ~10–15%; FastPass can address about a quarter → US$500–700M over 2026–30, ≈ US$100–140M a year.
-Demand signals: 7 in 10 airlines adopting biometric ID by 2026 (SITA 2024); ~78% of ME/SEA projects are brownfield — where an infrastructure-light lane wins.
-Correction from draft: CAGR is 14.4% (MarketsandMarkets), not ~14.5%.</a:t>
+              <a:t>[0:55–1:45]  Market Potential
+This is a large and growing market.
+Automated border control will reach about 5 billion US dollars by 2030, growing over 14 percent a year. Most of it is at airports.
+We focus on the Middle East and Southeast Asia, where traffic grows fastest. That gives us a market of 500 to 700 million US dollars over five years. That's about 100 to 140 million a year.
+And the timing is right. Seven in ten airlines are adopting biometric ID by 2026. And almost 80 percent of airport projects in these regions upgrade existing terminals. That is exactly where FastPass fits.</a:t>
             </a:r>
             <a:endParaRPr lang="en-US" dirty="0"/>
           </a:p>
@@ -1350,13 +1354,14 @@
           <a:p>
             <a:r>
               <a:rPr lang="en-US" dirty="0"/>
-              <a:t>[1:45–2:55]  One slide, the whole journey. Follow the cyan line:
-1 Enrol at home — passport + selfie in the FastPass Mobile App (or the airport/airline app via SDK); the credential stays encrypted on the phone.
-2 Approach — BLE pairs the phone to the lane as the traveller walks up.
-3 Walk through immigration — the Biometric E-Gate's FR pylon matches face to phone on the move; the status TV beside the pylon flashes the traveller's name and a green CLEARED.
-4 Pre-screen — the Pre-Screening Profile Check reader confirms identity before bags reach X-ray.
-5 Board — face + phone clears the Smart Boarding Kiosk; no passport, no boarding pass.
-6 Oversee — AGIL® Secure ISMP sees every step; amber exceptions go to an officer's tablet.</a:t>
+              <a:t>[1:45–2:45]  Solution: the journey
+So how does it work? Please follow the blue line.
+One. At home, the traveller enrols once in the FastPass app: a passport scan and a selfie. The credential stays safely on the phone.
+Two. As they walk up to the lane, the phone connects to it by Bluetooth. It stays in the pocket.
+Three. They walk through the e-gate. The camera matches the face to the phone, without stopping. The screen next to the gate shows their name and a green "Cleared".
+Four. Before security screening, a profile check confirms it is the same person.
+Five. At the gate, the boarding kiosk clears them by face. No passport. No boarding pass.
+Six. And the control room sees every step. Officers step in only when something needs attention.</a:t>
             </a:r>
             <a:endParaRPr lang="en-US" dirty="0"/>
           </a:p>
@@ -1444,8 +1449,10 @@
           <a:p>
             <a:r>
               <a:rPr lang="en-US" dirty="0"/>
-              <a:t>[2:55–3:30]  Behind the journey is AGIL® Secure ISMP — one command environment: traveller transactions, lane and gate control, exception management, assistive AI, a 3D operational view and physical security (CCTV, access, intrusion).
-The screen is the live product: passenger log with clear/fail status, traffic, and the departures map. [Swap in the incident-management / digital-twin screenshot from the airshow build if available.]</a:t>
+              <a:t>[2:45–3:15]  AGIL Secure ISMP
+That control room runs on AGIL Secure ISMP, our existing platform.
+It brings everything into one place: traveller clearances, lanes and gates, alerts, CCTV and access control, a 3D view of the terminal, and AI that helps operators act faster.
+On the right is the real product: a live passenger log, passenger flow by zone, and exceptions flagged for action.</a:t>
             </a:r>
             <a:endParaRPr lang="en-US" dirty="0"/>
           </a:p>
@@ -1533,12 +1540,10 @@
           <a:p>
             <a:r>
               <a:rPr lang="en-US" dirty="0"/>
-              <a:t>[3:30–4:20]  "The magic is the clearance method, not the turnstile" (CEO).
-Two factors on the move — the phone credential via BLE plus the live face. Most walk-through lanes we benchmarked verify the face only.
-• Privacy by design: passport and face template stay encrypted on the phone; the airport holds no biometric database.
-• Plugs into existing apps: an SDK for airport and airline channels — the app is an enabler.
-• Converged: every clearance sits beside CCTV, access control and incidents in ISMP.
-• AI in the offering and the build: on-the-move facial recognition, assistive alert triage; AI-assisted engineering cut selected front-end effort ~50%.</a:t>
+              <a:t>[3:15–4:00]  Innovativeness
+So where is the innovation? It's not another gate. It's the credential.
+Most walk-through lanes check one thing: your face. FastPass checks two things at once, while you walk. The phone proves the credential. The face proves the person.
+It is also built differently. Data stays encrypted on the traveller's phone, not in an airport database. It plugs into the apps airports and airlines already have. It is joined up with security operations. And we use AI in the product, for face matching and alerts, and in how we build it, cutting front-end effort by about half.</a:t>
             </a:r>
             <a:endParaRPr lang="en-US" dirty="0"/>
           </a:p>
@@ -1626,11 +1631,12 @@
           <a:p>
             <a:r>
               <a:rPr lang="en-US" dirty="0"/>
-              <a:t>[4:20–5:00]  Productivity and ROI (Market Potential &amp; Business Impact criterion).
-Watch the loop: today's traveller stops at every checkpoint; the FastPass traveller glides through.
-• Passengers: zero intentional stops; curb to gate in 8–11 minutes (target, validated at the airport demo).
-• Operators: four touchpoints automated — officers move from routine checks to exceptions. The ROI case is officer hours plus capacity without new terminal space.
-• Security: one view of every lane, clearance and incident in ISMP.</a:t>
+              <a:t>[4:00–4:40]  Business Impact
+What does this mean for each group?
+Look at the two lines. Today, the traveller stops four times. With FastPass, they keep moving.
+For passengers: zero stops. Our target is curb to gate in 8 to 11 minutes.
+For operators: all four touchpoints are automated, so officers focus only on exceptions. That is the return on investment: fewer officer hours, and more capacity without new buildings.
+For security: one view of every lane, every clearance and every incident.</a:t>
             </a:r>
             <a:endParaRPr lang="en-US" dirty="0"/>
           </a:p>
@@ -1718,9 +1724,11 @@
           <a:p>
             <a:r>
               <a:rPr lang="en-US" dirty="0"/>
-              <a:t>[5:00–5:50]  Who buys: Tier-2 international airports in the Middle East and Southeast Asia; immigration and border agencies co-decide; airlines enable adoption through their digital channels.
-What they pay for: lane hardware (one-off), ISMP licence (recurring, by scope), integration (project), annual support and SLA. [Insert target price points after the Sales sync.]
-How we scale: prove one pilot lane → expand lanes and enrolment → connect every touchpoint via ISMP → scale across terminals and portfolios. Reusing the live ISMP core keeps development fast.</a:t>
+              <a:t>[4:40–5:20]  Time to Market
+How do we go to market?
+Our buyers are Tier-2 international airports in the Middle East and Southeast Asia. Immigration agencies decide with them. Airlines help through their own apps.
+The model is simple: a one-off sale for lane hardware, a recurring ISMP licence, project fees for integration, and annual support.
+And we grow step by step. Prove it with one pilot lane. Expand to more lanes. Connect every touchpoint through ISMP. Then scale across terminals and airports. Because ISMP is already running, we can move fast.</a:t>
             </a:r>
             <a:endParaRPr lang="en-US" dirty="0"/>
           </a:p>
@@ -1808,11 +1816,10 @@
           <a:p>
             <a:r>
               <a:rPr lang="en-US" dirty="0"/>
-              <a:t>[5:50–6:35]  MARKET POTENTIAL — "collaborative initiative across BAs" is 30% of that score — and ENTRY BARRIERS (strong IP, deep know-how, specialised set-up, strong sales network) plus "effort to scale fast".
-Collaboration: one product team across Smart Security &amp; Automation, Smart Utilities &amp; Infrastructure and Urban Solutions — product, mobile, biometrics, e-gate, the ISMP platform team — with Group Sales engaged. [Confirm each BA's named contribution.]
-Barriers: owned IP across the app, lane logic and ISMP; 35+ years of mission-critical delivery; a specialised set-up that converges clearance with security operations; the Group's sales reach in ME &amp; SE Asia.
-Scaling fast: cross-sell through Group BUs in other countries; regional sales and integration partners; international requirements already built in (privacy rules, airport governance models, manual-lane fallback). [Name the countries/BUs with Group Sales before 22 Oct.]
-If asked about Idemia: they lead on portfolio breadth; we lead on two-factor clearance and converged security operations.</a:t>
+              <a:t>[5:20–6:10]  Collaboration &amp; Entry Barriers
+FastPass is built across three business areas, as one product team, from biometrics to sales.
+That is also what makes it hard to copy. We own the IP: the app, the lane logic and ISMP. We bring over 35 years of mission-critical experience. We have a specialised set-up that joins clearance with security operations. And we have the Group's sales reach in our target regions.
+To scale fast, we will cross-sell through Group business units in other countries and work with regional partners. And we have already built in international needs, like privacy rules and a manual fallback.</a:t>
             </a:r>
             <a:endParaRPr lang="en-US" dirty="0"/>
           </a:p>

</xml_diff>